<commit_message>
Updated slide and created model selection script.
</commit_message>
<xml_diff>
--- a/output/2026dsa_teamx.pptx
+++ b/output/2026dsa_teamx.pptx
@@ -104,6 +104,11 @@
       </a:defRPr>
     </a:lvl9pPr>
   </p:defaultTextStyle>
+  <p:extLst>
+    <p:ext uri="{EFAFB233-063F-42B5-8137-9DF3F51BA10A}">
+      <p15:sldGuideLst xmlns:p15="http://schemas.microsoft.com/office/powerpoint/2012/main"/>
+    </p:ext>
+  </p:extLst>
 </p:presentation>
 </file>
 
@@ -254,7 +259,7 @@
           <a:p>
             <a:fld id="{854E60CA-E60B-3C4A-A6C2-C45FCFAB7068}" type="datetimeFigureOut">
               <a:rPr lang="en-US" smtClean="0"/>
-              <a:t>3/30/26</a:t>
+              <a:t>4/19/2026</a:t>
             </a:fld>
             <a:endParaRPr lang="en-US"/>
           </a:p>
@@ -452,7 +457,7 @@
           <a:p>
             <a:fld id="{854E60CA-E60B-3C4A-A6C2-C45FCFAB7068}" type="datetimeFigureOut">
               <a:rPr lang="en-US" smtClean="0"/>
-              <a:t>3/30/26</a:t>
+              <a:t>4/19/2026</a:t>
             </a:fld>
             <a:endParaRPr lang="en-US"/>
           </a:p>
@@ -660,7 +665,7 @@
           <a:p>
             <a:fld id="{854E60CA-E60B-3C4A-A6C2-C45FCFAB7068}" type="datetimeFigureOut">
               <a:rPr lang="en-US" smtClean="0"/>
-              <a:t>3/30/26</a:t>
+              <a:t>4/19/2026</a:t>
             </a:fld>
             <a:endParaRPr lang="en-US"/>
           </a:p>
@@ -858,7 +863,7 @@
           <a:p>
             <a:fld id="{854E60CA-E60B-3C4A-A6C2-C45FCFAB7068}" type="datetimeFigureOut">
               <a:rPr lang="en-US" smtClean="0"/>
-              <a:t>3/30/26</a:t>
+              <a:t>4/19/2026</a:t>
             </a:fld>
             <a:endParaRPr lang="en-US"/>
           </a:p>
@@ -1133,7 +1138,7 @@
           <a:p>
             <a:fld id="{854E60CA-E60B-3C4A-A6C2-C45FCFAB7068}" type="datetimeFigureOut">
               <a:rPr lang="en-US" smtClean="0"/>
-              <a:t>3/30/26</a:t>
+              <a:t>4/19/2026</a:t>
             </a:fld>
             <a:endParaRPr lang="en-US"/>
           </a:p>
@@ -1398,7 +1403,7 @@
           <a:p>
             <a:fld id="{854E60CA-E60B-3C4A-A6C2-C45FCFAB7068}" type="datetimeFigureOut">
               <a:rPr lang="en-US" smtClean="0"/>
-              <a:t>3/30/26</a:t>
+              <a:t>4/19/2026</a:t>
             </a:fld>
             <a:endParaRPr lang="en-US"/>
           </a:p>
@@ -1810,7 +1815,7 @@
           <a:p>
             <a:fld id="{854E60CA-E60B-3C4A-A6C2-C45FCFAB7068}" type="datetimeFigureOut">
               <a:rPr lang="en-US" smtClean="0"/>
-              <a:t>3/30/26</a:t>
+              <a:t>4/19/2026</a:t>
             </a:fld>
             <a:endParaRPr lang="en-US"/>
           </a:p>
@@ -1951,7 +1956,7 @@
           <a:p>
             <a:fld id="{854E60CA-E60B-3C4A-A6C2-C45FCFAB7068}" type="datetimeFigureOut">
               <a:rPr lang="en-US" smtClean="0"/>
-              <a:t>3/30/26</a:t>
+              <a:t>4/19/2026</a:t>
             </a:fld>
             <a:endParaRPr lang="en-US"/>
           </a:p>
@@ -2064,7 +2069,7 @@
           <a:p>
             <a:fld id="{854E60CA-E60B-3C4A-A6C2-C45FCFAB7068}" type="datetimeFigureOut">
               <a:rPr lang="en-US" smtClean="0"/>
-              <a:t>3/30/26</a:t>
+              <a:t>4/19/2026</a:t>
             </a:fld>
             <a:endParaRPr lang="en-US"/>
           </a:p>
@@ -2375,7 +2380,7 @@
           <a:p>
             <a:fld id="{854E60CA-E60B-3C4A-A6C2-C45FCFAB7068}" type="datetimeFigureOut">
               <a:rPr lang="en-US" smtClean="0"/>
-              <a:t>3/30/26</a:t>
+              <a:t>4/19/2026</a:t>
             </a:fld>
             <a:endParaRPr lang="en-US"/>
           </a:p>
@@ -2663,7 +2668,7 @@
           <a:p>
             <a:fld id="{854E60CA-E60B-3C4A-A6C2-C45FCFAB7068}" type="datetimeFigureOut">
               <a:rPr lang="en-US" smtClean="0"/>
-              <a:t>3/30/26</a:t>
+              <a:t>4/19/2026</a:t>
             </a:fld>
             <a:endParaRPr lang="en-US"/>
           </a:p>
@@ -2904,7 +2909,7 @@
           <a:p>
             <a:fld id="{854E60CA-E60B-3C4A-A6C2-C45FCFAB7068}" type="datetimeFigureOut">
               <a:rPr lang="en-US" smtClean="0"/>
-              <a:t>3/30/26</a:t>
+              <a:t>4/19/2026</a:t>
             </a:fld>
             <a:endParaRPr lang="en-US"/>
           </a:p>
@@ -3370,7 +3375,7 @@
         </p:nvSpPr>
         <p:spPr>
           <a:xfrm>
-            <a:off x="918519" y="456514"/>
+            <a:off x="422760" y="456514"/>
             <a:ext cx="5177481" cy="1692771"/>
           </a:xfrm>
           <a:prstGeom prst="rect">
@@ -3386,23 +3391,22 @@
           <a:p>
             <a:pPr algn="ctr"/>
             <a:r>
-              <a:rPr lang="en-US" sz="4000" b="1" u="sng"/>
+              <a:rPr lang="en-US" sz="4000" b="1" u="sng" dirty="0"/>
               <a:t>Team x</a:t>
             </a:r>
-            <a:endParaRPr lang="en-US" sz="4000" b="1" u="sng" dirty="0"/>
           </a:p>
           <a:p>
             <a:pPr algn="ctr"/>
             <a:r>
               <a:rPr lang="en-US" sz="3200" dirty="0"/>
-              <a:t>John Doe</a:t>
+              <a:t>Elizabeth Abati</a:t>
             </a:r>
           </a:p>
           <a:p>
             <a:pPr algn="ctr"/>
             <a:r>
               <a:rPr lang="en-US" sz="3200" dirty="0"/>
-              <a:t>Jane Doe</a:t>
+              <a:t>Susmitha Kalli</a:t>
             </a:r>
           </a:p>
         </p:txBody>
@@ -3422,7 +3426,7 @@
           <p:nvPr>
             <p:extLst>
               <p:ext uri="{D42A27DB-BD31-4B8C-83A1-F6EECF244321}">
-                <p14:modId xmlns:p14="http://schemas.microsoft.com/office/powerpoint/2010/main" val="4253389279"/>
+                <p14:modId xmlns:p14="http://schemas.microsoft.com/office/powerpoint/2010/main" val="465445342"/>
               </p:ext>
             </p:extLst>
           </p:nvPr>
@@ -3561,9 +3565,10 @@
                     <a:lstStyle/>
                     <a:p>
                       <a:r>
-                        <a:rPr lang="en-US" sz="2400" dirty="0"/>
+                        <a:rPr lang="en-US" sz="2400"/>
                         <a:t>2</a:t>
                       </a:r>
+                      <a:endParaRPr lang="en-US" sz="2400" dirty="0"/>
                     </a:p>
                   </a:txBody>
                   <a:tcPr/>
@@ -3640,14 +3645,14 @@
           <p:nvPr>
             <p:extLst>
               <p:ext uri="{D42A27DB-BD31-4B8C-83A1-F6EECF244321}">
-                <p14:modId xmlns:p14="http://schemas.microsoft.com/office/powerpoint/2010/main" val="2827846898"/>
+                <p14:modId xmlns:p14="http://schemas.microsoft.com/office/powerpoint/2010/main" val="1455202679"/>
               </p:ext>
             </p:extLst>
           </p:nvPr>
         </p:nvGraphicFramePr>
         <p:xfrm>
           <a:off x="5514417" y="1466415"/>
-          <a:ext cx="6118606" cy="4754880"/>
+          <a:ext cx="6118606" cy="5022525"/>
         </p:xfrm>
         <a:graphic>
           <a:graphicData uri="http://schemas.openxmlformats.org/drawingml/2006/table">
@@ -3671,14 +3676,14 @@
                   </a:extLst>
                 </a:gridCol>
               </a:tblGrid>
-              <a:tr h="370840">
+              <a:tr h="370982">
                 <a:tc>
                   <a:txBody>
                     <a:bodyPr/>
                     <a:lstStyle/>
                     <a:p>
                       <a:r>
-                        <a:rPr lang="en-US" sz="2000" dirty="0"/>
+                        <a:rPr lang="en-US" sz="1200" dirty="0"/>
                         <a:t>Parameter</a:t>
                       </a:r>
                     </a:p>
@@ -3698,7 +3703,7 @@
                     <a:lstStyle/>
                     <a:p>
                       <a:r>
-                        <a:rPr lang="en-US" sz="2000" dirty="0"/>
+                        <a:rPr lang="en-US" sz="1200" dirty="0"/>
                         <a:t>Value</a:t>
                       </a:r>
                     </a:p>
@@ -3718,14 +3723,14 @@
                   </a:ext>
                 </a:extLst>
               </a:tr>
-              <a:tr h="370840">
+              <a:tr h="370982">
                 <a:tc>
                   <a:txBody>
                     <a:bodyPr/>
                     <a:lstStyle/>
                     <a:p>
                       <a:r>
-                        <a:rPr lang="en-US" sz="2000" b="0" i="1" dirty="0"/>
+                        <a:rPr lang="en-US" sz="1200" b="0" i="1" dirty="0"/>
                         <a:t>Data engineering approach</a:t>
                       </a:r>
                     </a:p>
@@ -3738,8 +3743,8 @@
                     <a:lstStyle/>
                     <a:p>
                       <a:r>
-                        <a:rPr lang="en-US" sz="2000" dirty="0"/>
-                        <a:t>Month, mean/sum</a:t>
+                        <a:rPr lang="en-US" sz="1200" dirty="0"/>
+                        <a:t>sum</a:t>
                       </a:r>
                     </a:p>
                   </a:txBody>
@@ -3751,14 +3756,14 @@
                   </a:ext>
                 </a:extLst>
               </a:tr>
-              <a:tr h="370840">
+              <a:tr h="370982">
                 <a:tc>
                   <a:txBody>
                     <a:bodyPr/>
                     <a:lstStyle/>
                     <a:p>
                       <a:r>
-                        <a:rPr lang="en-US" sz="2000" b="0" i="1" dirty="0"/>
+                        <a:rPr lang="en-US" sz="1200" b="0" i="1" dirty="0"/>
                         <a:t>Number of predictors</a:t>
                       </a:r>
                     </a:p>
@@ -3771,8 +3776,8 @@
                     <a:lstStyle/>
                     <a:p>
                       <a:r>
-                        <a:rPr lang="en-US" sz="2000" dirty="0"/>
-                        <a:t>72</a:t>
+                        <a:rPr lang="en-US" sz="1200" dirty="0"/>
+                        <a:t>27</a:t>
                       </a:r>
                     </a:p>
                   </a:txBody>
@@ -3784,14 +3789,14 @@
                   </a:ext>
                 </a:extLst>
               </a:tr>
-              <a:tr h="370840">
+              <a:tr h="370982">
                 <a:tc>
                   <a:txBody>
                     <a:bodyPr/>
                     <a:lstStyle/>
                     <a:p>
                       <a:r>
-                        <a:rPr lang="en-US" sz="2000" b="0" i="1" dirty="0"/>
+                        <a:rPr lang="en-US" sz="1200" b="0" i="1" dirty="0"/>
                         <a:t>Data split proportion</a:t>
                       </a:r>
                     </a:p>
@@ -3804,7 +3809,7 @@
                     <a:lstStyle/>
                     <a:p>
                       <a:r>
-                        <a:rPr lang="en-US" sz="2000" dirty="0"/>
+                        <a:rPr lang="en-US" sz="1200" dirty="0"/>
                         <a:t>70/30</a:t>
                       </a:r>
                     </a:p>
@@ -3817,14 +3822,14 @@
                   </a:ext>
                 </a:extLst>
               </a:tr>
-              <a:tr h="370840">
+              <a:tr h="370982">
                 <a:tc>
                   <a:txBody>
                     <a:bodyPr/>
                     <a:lstStyle/>
                     <a:p>
                       <a:r>
-                        <a:rPr lang="en-US" sz="2000" b="0" i="1" dirty="0"/>
+                        <a:rPr lang="en-US" sz="1200" b="0" i="1" dirty="0"/>
                         <a:t>Random or stratified?</a:t>
                       </a:r>
                     </a:p>
@@ -3837,7 +3842,7 @@
                     <a:lstStyle/>
                     <a:p>
                       <a:r>
-                        <a:rPr lang="en-US" sz="2000" dirty="0"/>
+                        <a:rPr lang="en-US" sz="1200" dirty="0"/>
                         <a:t>Stratified</a:t>
                       </a:r>
                     </a:p>
@@ -3850,14 +3855,14 @@
                   </a:ext>
                 </a:extLst>
               </a:tr>
-              <a:tr h="370840">
+              <a:tr h="370982">
                 <a:tc>
                   <a:txBody>
                     <a:bodyPr/>
                     <a:lstStyle/>
                     <a:p>
                       <a:r>
-                        <a:rPr lang="en-US" sz="2000" b="0" i="1" dirty="0"/>
+                        <a:rPr lang="en-US" sz="1200" b="0" i="1" dirty="0"/>
                         <a:t>If stratified, by which variable?</a:t>
                       </a:r>
                     </a:p>
@@ -3870,10 +3875,10 @@
                     <a:lstStyle/>
                     <a:p>
                       <a:r>
-                        <a:rPr lang="en-US" sz="2000" dirty="0" err="1"/>
-                        <a:t>strenght_gtex</a:t>
+                        <a:rPr lang="en-US" sz="1200" dirty="0" err="1"/>
+                        <a:t>yield_mg_ma</a:t>
                       </a:r>
-                      <a:endParaRPr lang="en-US" sz="2000" dirty="0"/>
+                      <a:endParaRPr lang="en-US" sz="1200" dirty="0"/>
                     </a:p>
                   </a:txBody>
                   <a:tcPr/>
@@ -3884,14 +3889,14 @@
                   </a:ext>
                 </a:extLst>
               </a:tr>
-              <a:tr h="370840">
+              <a:tr h="370982">
                 <a:tc>
                   <a:txBody>
                     <a:bodyPr/>
                     <a:lstStyle/>
                     <a:p>
                       <a:r>
-                        <a:rPr lang="en-US" sz="2000" b="0" i="1" dirty="0"/>
+                        <a:rPr lang="en-US" sz="1200" b="0" i="1" dirty="0"/>
                         <a:t>Pre-processing steps</a:t>
                       </a:r>
                     </a:p>
@@ -3904,8 +3909,8 @@
                     <a:lstStyle/>
                     <a:p>
                       <a:r>
-                        <a:rPr lang="en-US" sz="2000" dirty="0"/>
-                        <a:t>Normalized, PCA</a:t>
+                        <a:rPr lang="en-US" sz="1200" dirty="0"/>
+                        <a:t>Normalized</a:t>
                       </a:r>
                     </a:p>
                   </a:txBody>
@@ -3917,14 +3922,14 @@
                   </a:ext>
                 </a:extLst>
               </a:tr>
-              <a:tr h="370840">
+              <a:tr h="941723">
                 <a:tc>
                   <a:txBody>
                     <a:bodyPr/>
                     <a:lstStyle/>
                     <a:p>
                       <a:r>
-                        <a:rPr lang="en-US" sz="2000" b="0" i="1" dirty="0"/>
+                        <a:rPr lang="en-US" sz="1200" b="0" i="1" dirty="0"/>
                         <a:t>Name of hyperparameters tuned</a:t>
                       </a:r>
                     </a:p>
@@ -3937,18 +3942,45 @@
                     <a:lstStyle/>
                     <a:p>
                       <a:r>
-                        <a:rPr lang="en-US" sz="2000" dirty="0" err="1"/>
-                        <a:t>Mtry</a:t>
+                        <a:rPr lang="en-US" sz="1200" dirty="0" err="1"/>
+                        <a:t>mtry</a:t>
                       </a:r>
                       <a:r>
-                        <a:rPr lang="en-US" sz="2000" dirty="0"/>
+                        <a:rPr lang="en-US" sz="1200" dirty="0"/>
+                        <a:t>, trees, </a:t>
+                      </a:r>
+                      <a:r>
+                        <a:rPr lang="en-US" sz="1200" dirty="0" err="1"/>
+                        <a:t>tree_depth</a:t>
+                      </a:r>
+                      <a:r>
+                        <a:rPr lang="en-US" sz="1200" dirty="0"/>
                         <a:t>, </a:t>
                       </a:r>
                       <a:r>
-                        <a:rPr lang="en-US" sz="2000" dirty="0" err="1"/>
-                        <a:t>ntrees</a:t>
+                        <a:rPr lang="en-US" sz="1200" dirty="0" err="1"/>
+                        <a:t>learn_rate</a:t>
                       </a:r>
-                      <a:endParaRPr lang="en-US" sz="2000" dirty="0"/>
+                      <a:r>
+                        <a:rPr lang="en-US" sz="1200" dirty="0"/>
+                        <a:t>, </a:t>
+                      </a:r>
+                      <a:r>
+                        <a:rPr lang="en-US" sz="1200" dirty="0" err="1"/>
+                        <a:t>loss_reduction</a:t>
+                      </a:r>
+                      <a:r>
+                        <a:rPr lang="en-US" sz="1200" dirty="0"/>
+                        <a:t>, </a:t>
+                      </a:r>
+                      <a:r>
+                        <a:rPr lang="en-US" sz="1200" dirty="0" err="1"/>
+                        <a:t>sample_size</a:t>
+                      </a:r>
+                      <a:r>
+                        <a:rPr lang="en-US" sz="1200" dirty="0"/>
+                        <a:t>,  error rate, width of RBF</a:t>
+                      </a:r>
                     </a:p>
                   </a:txBody>
                   <a:tcPr/>
@@ -3959,14 +3991,14 @@
                   </a:ext>
                 </a:extLst>
               </a:tr>
-              <a:tr h="370840">
+              <a:tr h="370982">
                 <a:tc>
                   <a:txBody>
                     <a:bodyPr/>
                     <a:lstStyle/>
                     <a:p>
                       <a:r>
-                        <a:rPr lang="en-US" sz="2000" b="0" i="1" dirty="0"/>
+                        <a:rPr lang="en-US" sz="1200" b="0" i="1" dirty="0"/>
                         <a:t>Search algorithm</a:t>
                       </a:r>
                     </a:p>
@@ -3979,8 +4011,8 @@
                     <a:lstStyle/>
                     <a:p>
                       <a:r>
-                        <a:rPr lang="en-US" sz="2000" dirty="0"/>
-                        <a:t>Sim. annealing</a:t>
+                        <a:rPr lang="en-US" sz="1200" dirty="0"/>
+                        <a:t>Grid search</a:t>
                       </a:r>
                     </a:p>
                   </a:txBody>
@@ -3992,14 +4024,14 @@
                   </a:ext>
                 </a:extLst>
               </a:tr>
-              <a:tr h="370840">
+              <a:tr h="370982">
                 <a:tc>
                   <a:txBody>
                     <a:bodyPr/>
                     <a:lstStyle/>
                     <a:p>
                       <a:r>
-                        <a:rPr lang="en-US" sz="2000" b="0" i="1" dirty="0"/>
+                        <a:rPr lang="en-US" sz="1200" b="0" i="1" dirty="0"/>
                         <a:t>V value</a:t>
                       </a:r>
                     </a:p>
@@ -4012,7 +4044,7 @@
                     <a:lstStyle/>
                     <a:p>
                       <a:r>
-                        <a:rPr lang="en-US" sz="2000" dirty="0"/>
+                        <a:rPr lang="en-US" sz="1200" dirty="0"/>
                         <a:t>5</a:t>
                       </a:r>
                     </a:p>
@@ -4025,14 +4057,14 @@
                   </a:ext>
                 </a:extLst>
               </a:tr>
-              <a:tr h="370840">
+              <a:tr h="370982">
                 <a:tc>
                   <a:txBody>
                     <a:bodyPr/>
                     <a:lstStyle/>
                     <a:p>
                       <a:r>
-                        <a:rPr lang="en-US" sz="2000" b="0" i="1" dirty="0"/>
+                        <a:rPr lang="en-US" sz="1200" b="0" i="1" dirty="0"/>
                         <a:t>Metric used to select best model</a:t>
                       </a:r>
                     </a:p>
@@ -4045,7 +4077,7 @@
                     <a:lstStyle/>
                     <a:p>
                       <a:r>
-                        <a:rPr lang="en-US" sz="2000" dirty="0"/>
+                        <a:rPr lang="en-US" sz="1200" dirty="0"/>
                         <a:t>R2</a:t>
                       </a:r>
                     </a:p>
@@ -4058,22 +4090,22 @@
                   </a:ext>
                 </a:extLst>
               </a:tr>
-              <a:tr h="370840">
+              <a:tr h="370982">
                 <a:tc>
                   <a:txBody>
                     <a:bodyPr/>
                     <a:lstStyle/>
                     <a:p>
                       <a:r>
-                        <a:rPr lang="en-US" sz="2000" b="0" i="1" dirty="0"/>
+                        <a:rPr lang="en-US" sz="1200" b="0" i="1" dirty="0"/>
                         <a:t>Type of best (overall, within 1 </a:t>
                       </a:r>
                       <a:r>
-                        <a:rPr lang="en-US" sz="2000" b="0" i="1" dirty="0" err="1"/>
+                        <a:rPr lang="en-US" sz="1200" b="0" i="1" dirty="0" err="1"/>
                         <a:t>sd</a:t>
                       </a:r>
                       <a:r>
-                        <a:rPr lang="en-US" sz="2000" b="0" i="1" dirty="0"/>
+                        <a:rPr lang="en-US" sz="1200" b="0" i="1" dirty="0"/>
                         <a:t>)</a:t>
                       </a:r>
                     </a:p>
@@ -4086,7 +4118,7 @@
                     <a:lstStyle/>
                     <a:p>
                       <a:r>
-                        <a:rPr lang="en-US" sz="2000" dirty="0"/>
+                        <a:rPr lang="en-US" sz="1200" dirty="0"/>
                         <a:t>Overall</a:t>
                       </a:r>
                     </a:p>

</xml_diff>

<commit_message>
updated slide with pre-processing steps
</commit_message>
<xml_diff>
--- a/output/2026dsa_teamx.pptx
+++ b/output/2026dsa_teamx.pptx
@@ -3565,10 +3565,9 @@
                     <a:lstStyle/>
                     <a:p>
                       <a:r>
-                        <a:rPr lang="en-US" sz="2400"/>
+                        <a:rPr lang="en-US" sz="2400" dirty="0"/>
                         <a:t>2</a:t>
                       </a:r>
-                      <a:endParaRPr lang="en-US" sz="2400" dirty="0"/>
                     </a:p>
                   </a:txBody>
                   <a:tcPr/>
@@ -3645,7 +3644,7 @@
           <p:nvPr>
             <p:extLst>
               <p:ext uri="{D42A27DB-BD31-4B8C-83A1-F6EECF244321}">
-                <p14:modId xmlns:p14="http://schemas.microsoft.com/office/powerpoint/2010/main" val="1455202679"/>
+                <p14:modId xmlns:p14="http://schemas.microsoft.com/office/powerpoint/2010/main" val="869337371"/>
               </p:ext>
             </p:extLst>
           </p:nvPr>
@@ -3744,7 +3743,7 @@
                     <a:p>
                       <a:r>
                         <a:rPr lang="en-US" sz="1200" dirty="0"/>
-                        <a:t>sum</a:t>
+                        <a:t>subtraction</a:t>
                       </a:r>
                     </a:p>
                   </a:txBody>
@@ -3947,7 +3946,15 @@
                       </a:r>
                       <a:r>
                         <a:rPr lang="en-US" sz="1200" dirty="0"/>
-                        <a:t>, trees, </a:t>
+                        <a:t>, </a:t>
+                      </a:r>
+                      <a:r>
+                        <a:rPr lang="en-US" sz="1200" dirty="0" err="1"/>
+                        <a:t>ntrees</a:t>
+                      </a:r>
+                      <a:r>
+                        <a:rPr lang="en-US" sz="1200" dirty="0"/>
+                        <a:t>, </a:t>
                       </a:r>
                       <a:r>
                         <a:rPr lang="en-US" sz="1200" dirty="0" err="1"/>

</xml_diff>